<commit_message>
Deck: four snapshot pages and live screenshots with the 3D customer
Co-Authored-By: Claude Opus 5.5 <noreply@anthropic.com>
</commit_message>
<xml_diff>
--- a/media/SkillCoach_Submission.pptx
+++ b/media/SkillCoach_Submission.pptx
@@ -18,6 +18,9 @@
     <p:sldId id="264" r:id="rId14"/>
     <p:sldId id="265" r:id="rId15"/>
     <p:sldId id="266" r:id="rId16"/>
+    <p:sldId id="274" r:id="rId30"/>
+    <p:sldId id="273" r:id="rId29"/>
+    <p:sldId id="272" r:id="rId28"/>
     <p:sldId id="267" r:id="rId17"/>
     <p:sldId id="268" r:id="rId18"/>
     <p:sldId id="269" r:id="rId19"/>
@@ -8437,7 +8440,7 @@
                 <a:cs typeface="Google Sans Flex Medium"/>
                 <a:sym typeface="Google Sans Flex Medium"/>
               </a:rPr>
-              <a:t>Snapshots of the prototype</a:t>
+              <a:t>Snapshots of the prototype: practice</a:t>
             </a:r>
             <a:endParaRPr sz="1600">
               <a:latin typeface="Google Sans Flex Medium"/>
@@ -8450,7 +8453,7 @@
       </p:sp>
       <p:pic>
         <p:nvPicPr>
-          <p:cNvPr id="136" name="Picture 135" descr="compliance-guard.png"/>
+          <p:cNvPr id="136" name="Picture 135" descr="practice_start.jpg"/>
           <p:cNvPicPr>
             <a:picLocks noChangeAspect="1"/>
           </p:cNvPicPr>
@@ -8464,8 +8467,8 @@
         </p:blipFill>
         <p:spPr>
           <a:xfrm>
-            <a:off x="974343" y="1207007"/>
-            <a:ext cx="2861056" cy="1609344"/>
+            <a:off x="320040" y="1207008"/>
+            <a:ext cx="4169663" cy="2606039"/>
           </a:xfrm>
           <a:prstGeom prst="rect">
             <a:avLst/>
@@ -8485,8 +8488,8 @@
         </p:nvSpPr>
         <p:spPr>
           <a:xfrm>
-            <a:off x="320040" y="2843784"/>
-            <a:ext cx="4169663" cy="201168"/>
+            <a:off x="320040" y="3922776"/>
+            <a:ext cx="4169663" cy="822960"/>
           </a:xfrm>
           <a:prstGeom prst="rect">
             <a:avLst/>
@@ -8505,20 +8508,20 @@
               </a:spcAft>
             </a:pPr>
             <a:r>
-              <a:rPr sz="900" i="1">
-                <a:solidFill>
-                  <a:srgbClr val="5F6368"/>
+              <a:rPr sz="1000" i="0">
+                <a:solidFill>
+                  <a:srgbClr val="202124"/>
                 </a:solidFill>
                 <a:latin typeface="Google Sans Flex"/>
               </a:rPr>
-              <a:t>Practice: the Compliance Guard holds a risky promise (CC-01)</a:t>
+              <a:t>Mr. Tan as a 3D customer: he blinks, breathes, keeps eye contact and lip-syncs. His mood follows the trust and patience meters.</a:t>
             </a:r>
           </a:p>
         </p:txBody>
       </p:sp>
       <p:pic>
         <p:nvPicPr>
-          <p:cNvPr id="138" name="Picture 137" descr="report.png"/>
+          <p:cNvPr id="138" name="Picture 137" descr="practice_guard.jpg"/>
           <p:cNvPicPr>
             <a:picLocks noChangeAspect="1"/>
           </p:cNvPicPr>
@@ -8532,8 +8535,8 @@
         </p:blipFill>
         <p:spPr>
           <a:xfrm>
-            <a:off x="5308599" y="1207007"/>
-            <a:ext cx="2861056" cy="1609344"/>
+            <a:off x="4654295" y="1207008"/>
+            <a:ext cx="4169663" cy="2606039"/>
           </a:xfrm>
           <a:prstGeom prst="rect">
             <a:avLst/>
@@ -8553,8 +8556,8 @@
         </p:nvSpPr>
         <p:spPr>
           <a:xfrm>
-            <a:off x="4654295" y="2843784"/>
-            <a:ext cx="4169663" cy="201168"/>
+            <a:off x="4654295" y="3922776"/>
+            <a:ext cx="4169663" cy="822960"/>
           </a:xfrm>
           <a:prstGeom prst="rect">
             <a:avLst/>
@@ -8573,149 +8576,13 @@
               </a:spcAft>
             </a:pPr>
             <a:r>
-              <a:rPr sz="900" i="1">
-                <a:solidFill>
-                  <a:srgbClr val="5F6368"/>
+              <a:rPr sz="1000" i="0">
+                <a:solidFill>
+                  <a:srgbClr val="202124"/>
                 </a:solidFill>
                 <a:latin typeface="Google Sans Flex"/>
               </a:rPr>
-              <a:t>Report: compliance gate failed; every score quotes a turn</a:t>
-            </a:r>
-          </a:p>
-        </p:txBody>
-      </p:sp>
-      <p:pic>
-        <p:nvPicPr>
-          <p:cNvPr id="140" name="Picture 139" descr="persona_detail.png"/>
-          <p:cNvPicPr>
-            <a:picLocks noChangeAspect="1"/>
-          </p:cNvPicPr>
-          <p:nvPr/>
-        </p:nvPicPr>
-        <p:blipFill>
-          <a:blip r:embed="rId7"/>
-          <a:stretch>
-            <a:fillRect/>
-          </a:stretch>
-        </p:blipFill>
-        <p:spPr>
-          <a:xfrm>
-            <a:off x="974343" y="3127248"/>
-            <a:ext cx="2861056" cy="1609344"/>
-          </a:xfrm>
-          <a:prstGeom prst="rect">
-            <a:avLst/>
-          </a:prstGeom>
-          <a:ln w="9525">
-            <a:solidFill>
-              <a:srgbClr val="DADCE0"/>
-            </a:solidFill>
-          </a:ln>
-        </p:spPr>
-      </p:pic>
-      <p:sp>
-        <p:nvSpPr>
-          <p:cNvPr id="141" name="TextBox 140"/>
-          <p:cNvSpPr txBox="1"/>
-          <p:nvPr/>
-        </p:nvSpPr>
-        <p:spPr>
-          <a:xfrm>
-            <a:off x="320040" y="4764024"/>
-            <a:ext cx="4169663" cy="201168"/>
-          </a:xfrm>
-          <a:prstGeom prst="rect">
-            <a:avLst/>
-          </a:prstGeom>
-          <a:noFill/>
-        </p:spPr>
-        <p:txBody>
-          <a:bodyPr wrap="square" anchor="t" lIns="0" rIns="0" tIns="0" bIns="0">
-            <a:spAutoFit/>
-          </a:bodyPr>
-          <a:lstStyle/>
-          <a:p>
-            <a:pPr algn="l">
-              <a:spcAft>
-                <a:spcPts val="300"/>
-              </a:spcAft>
-            </a:pPr>
-            <a:r>
-              <a:rPr sz="900" i="1">
-                <a:solidFill>
-                  <a:srgbClr val="5F6368"/>
-                </a:solidFill>
-                <a:latin typeface="Google Sans Flex"/>
-              </a:rPr>
-              <a:t>Generated persona: needs and objections cite the source</a:t>
-            </a:r>
-          </a:p>
-        </p:txBody>
-      </p:sp>
-      <p:pic>
-        <p:nvPicPr>
-          <p:cNvPr id="142" name="Picture 141" descr="dashboard.png"/>
-          <p:cNvPicPr>
-            <a:picLocks noChangeAspect="1"/>
-          </p:cNvPicPr>
-          <p:nvPr/>
-        </p:nvPicPr>
-        <p:blipFill>
-          <a:blip r:embed="rId8"/>
-          <a:stretch>
-            <a:fillRect/>
-          </a:stretch>
-        </p:blipFill>
-        <p:spPr>
-          <a:xfrm>
-            <a:off x="5308599" y="3127248"/>
-            <a:ext cx="2861056" cy="1609344"/>
-          </a:xfrm>
-          <a:prstGeom prst="rect">
-            <a:avLst/>
-          </a:prstGeom>
-          <a:ln w="9525">
-            <a:solidFill>
-              <a:srgbClr val="DADCE0"/>
-            </a:solidFill>
-          </a:ln>
-        </p:spPr>
-      </p:pic>
-      <p:sp>
-        <p:nvSpPr>
-          <p:cNvPr id="143" name="TextBox 142"/>
-          <p:cNvSpPr txBox="1"/>
-          <p:nvPr/>
-        </p:nvSpPr>
-        <p:spPr>
-          <a:xfrm>
-            <a:off x="4654295" y="4764024"/>
-            <a:ext cx="4169663" cy="201168"/>
-          </a:xfrm>
-          <a:prstGeom prst="rect">
-            <a:avLst/>
-          </a:prstGeom>
-          <a:noFill/>
-        </p:spPr>
-        <p:txBody>
-          <a:bodyPr wrap="square" anchor="t" lIns="0" rIns="0" tIns="0" bIns="0">
-            <a:spAutoFit/>
-          </a:bodyPr>
-          <a:lstStyle/>
-          <a:p>
-            <a:pPr algn="l">
-              <a:spcAft>
-                <a:spcPts val="300"/>
-              </a:spcAft>
-            </a:pPr>
-            <a:r>
-              <a:rPr sz="900" i="1">
-                <a:solidFill>
-                  <a:srgbClr val="5F6368"/>
-                </a:solidFill>
-                <a:latin typeface="Google Sans Flex"/>
-              </a:rPr>
-              <a:t>Manager readiness view (sample team data, labeled in the app)</a:t>
+              <a:t>"This plan guarantees you 8% a year" is held before it is sent: the Guard quotes the words, names rule CC-01, and offers Edit message or Send anyway.</a:t>
             </a:r>
           </a:p>
         </p:txBody>
@@ -13259,6 +13126,918 @@
 </p:sld>
 </file>
 
+<file path=ppt/slides/slide17.xml><?xml version="1.0" encoding="utf-8"?>
+<p:sld xmlns:a="http://schemas.openxmlformats.org/drawingml/2006/main" xmlns:p="http://schemas.openxmlformats.org/presentationml/2006/main" xmlns:r="http://schemas.openxmlformats.org/officeDocument/2006/relationships">
+  <p:cSld>
+    <p:spTree>
+      <p:nvGrpSpPr>
+        <p:cNvPr id="1" name=""/>
+        <p:cNvGrpSpPr/>
+        <p:nvPr/>
+      </p:nvGrpSpPr>
+      <p:grpSpPr/>
+      <p:pic>
+        <p:nvPicPr>
+          <p:cNvPr id="132" name="Google Shape;132;p23" title="Frame 144.png"/>
+          <p:cNvPicPr preferRelativeResize="0"/>
+          <p:nvPr/>
+        </p:nvPicPr>
+        <p:blipFill rotWithShape="1">
+          <a:blip r:embed="rId2">
+            <a:alphaModFix/>
+          </a:blip>
+          <a:srcRect b="98001" l="0" r="0" t="0"/>
+          <a:stretch/>
+        </p:blipFill>
+        <p:spPr>
+          <a:xfrm>
+            <a:off x="0" y="5093562"/>
+            <a:ext cx="9144000" cy="54275"/>
+          </a:xfrm>
+          <a:prstGeom prst="rect">
+            <a:avLst/>
+          </a:prstGeom>
+          <a:noFill/>
+          <a:ln>
+            <a:noFill/>
+          </a:ln>
+        </p:spPr>
+      </p:pic>
+      <p:pic>
+        <p:nvPicPr>
+          <p:cNvPr id="133" name="Google Shape;133;p23" title="Group 427319979.png"/>
+          <p:cNvPicPr preferRelativeResize="0"/>
+          <p:nvPr/>
+        </p:nvPicPr>
+        <p:blipFill>
+          <a:blip r:embed="rId3">
+            <a:alphaModFix/>
+          </a:blip>
+          <a:stretch>
+            <a:fillRect/>
+          </a:stretch>
+        </p:blipFill>
+        <p:spPr>
+          <a:xfrm>
+            <a:off x="0" y="1"/>
+            <a:ext cx="9144000" cy="507359"/>
+          </a:xfrm>
+          <a:prstGeom prst="rect">
+            <a:avLst/>
+          </a:prstGeom>
+          <a:noFill/>
+          <a:ln>
+            <a:noFill/>
+          </a:ln>
+        </p:spPr>
+      </p:pic>
+      <p:sp>
+        <p:nvSpPr>
+          <p:cNvPr id="134" name="Google Shape;134;p23"/>
+          <p:cNvSpPr/>
+          <p:nvPr/>
+        </p:nvSpPr>
+        <p:spPr>
+          <a:xfrm>
+            <a:off x="-29250" y="5071875"/>
+            <a:ext cx="9173400" cy="97800"/>
+          </a:xfrm>
+          <a:prstGeom prst="rect">
+            <a:avLst/>
+          </a:prstGeom>
+          <a:solidFill>
+            <a:schemeClr val="dk1"/>
+          </a:solidFill>
+          <a:ln>
+            <a:noFill/>
+          </a:ln>
+        </p:spPr>
+        <p:txBody>
+          <a:bodyPr anchorCtr="0" anchor="ctr" bIns="91425" lIns="91425" spcFirstLastPara="1" rIns="91425" wrap="square" tIns="91425">
+            <a:noAutofit/>
+          </a:bodyPr>
+          <a:lstStyle/>
+          <a:p>
+            <a:pPr indent="0" lvl="0" marL="0" rtl="0" algn="ctr">
+              <a:spcBef>
+                <a:spcPts val="0"/>
+              </a:spcBef>
+              <a:spcAft>
+                <a:spcPts val="0"/>
+              </a:spcAft>
+              <a:buNone/>
+            </a:pPr>
+            <a:r>
+              <a:t/>
+            </a:r>
+            <a:endParaRPr/>
+          </a:p>
+        </p:txBody>
+      </p:sp>
+      <p:sp>
+        <p:nvSpPr>
+          <p:cNvPr id="135" name="Google Shape;135;p23"/>
+          <p:cNvSpPr txBox="1"/>
+          <p:nvPr/>
+        </p:nvSpPr>
+        <p:spPr>
+          <a:xfrm>
+            <a:off x="265350" y="663825"/>
+            <a:ext cx="8943000" cy="457200"/>
+          </a:xfrm>
+          <a:prstGeom prst="rect">
+            <a:avLst/>
+          </a:prstGeom>
+          <a:noFill/>
+          <a:ln>
+            <a:noFill/>
+          </a:ln>
+        </p:spPr>
+        <p:txBody>
+          <a:bodyPr anchorCtr="0" anchor="t" bIns="91425" lIns="91425" spcFirstLastPara="1" rIns="91425" wrap="square" tIns="91425">
+            <a:noAutofit/>
+          </a:bodyPr>
+          <a:lstStyle/>
+          <a:p>
+            <a:pPr indent="0" lvl="0" marL="0" rtl="0" algn="l">
+              <a:spcBef>
+                <a:spcPts val="0"/>
+              </a:spcBef>
+              <a:spcAft>
+                <a:spcPts val="0"/>
+              </a:spcAft>
+              <a:buNone/>
+            </a:pPr>
+            <a:r>
+              <a:rPr lang="en-GB" sz="1600">
+                <a:latin typeface="Google Sans Flex Medium"/>
+                <a:ea typeface="Google Sans Flex Medium"/>
+                <a:cs typeface="Google Sans Flex Medium"/>
+                <a:sym typeface="Google Sans Flex Medium"/>
+              </a:rPr>
+              <a:t>Snapshots of the prototype: knowledge and team</a:t>
+            </a:r>
+            <a:endParaRPr sz="1600">
+              <a:latin typeface="Google Sans Flex Medium"/>
+              <a:ea typeface="Google Sans Flex Medium"/>
+              <a:cs typeface="Google Sans Flex Medium"/>
+              <a:sym typeface="Google Sans Flex Medium"/>
+            </a:endParaRPr>
+          </a:p>
+        </p:txBody>
+      </p:sp>
+      <p:pic>
+        <p:nvPicPr>
+          <p:cNvPr id="136" name="Picture 135" descr="persona_detail.jpg"/>
+          <p:cNvPicPr>
+            <a:picLocks noChangeAspect="1"/>
+          </p:cNvPicPr>
+          <p:nvPr/>
+        </p:nvPicPr>
+        <p:blipFill>
+          <a:blip r:embed="rId4"/>
+          <a:stretch>
+            <a:fillRect/>
+          </a:stretch>
+        </p:blipFill>
+        <p:spPr>
+          <a:xfrm>
+            <a:off x="320040" y="1207008"/>
+            <a:ext cx="4169663" cy="2606039"/>
+          </a:xfrm>
+          <a:prstGeom prst="rect">
+            <a:avLst/>
+          </a:prstGeom>
+          <a:ln w="9525">
+            <a:solidFill>
+              <a:srgbClr val="DADCE0"/>
+            </a:solidFill>
+          </a:ln>
+        </p:spPr>
+      </p:pic>
+      <p:sp>
+        <p:nvSpPr>
+          <p:cNvPr id="137" name="TextBox 136"/>
+          <p:cNvSpPr txBox="1"/>
+          <p:nvPr/>
+        </p:nvSpPr>
+        <p:spPr>
+          <a:xfrm>
+            <a:off x="320040" y="3922776"/>
+            <a:ext cx="4169663" cy="822960"/>
+          </a:xfrm>
+          <a:prstGeom prst="rect">
+            <a:avLst/>
+          </a:prstGeom>
+          <a:noFill/>
+        </p:spPr>
+        <p:txBody>
+          <a:bodyPr wrap="square" anchor="t" lIns="0" rIns="0" tIns="0" bIns="0">
+            <a:spAutoFit/>
+          </a:bodyPr>
+          <a:lstStyle/>
+          <a:p>
+            <a:pPr algn="l">
+              <a:spcAft>
+                <a:spcPts val="300"/>
+              </a:spcAft>
+            </a:pPr>
+            <a:r>
+              <a:rPr sz="1000" i="0">
+                <a:solidFill>
+                  <a:srgbClr val="202124"/>
+                </a:solidFill>
+                <a:latin typeface="Google Sans Flex"/>
+              </a:rPr>
+              <a:t>An approved persona: profile, hidden needs and objections, each grounded in cited source passages.</a:t>
+            </a:r>
+          </a:p>
+        </p:txBody>
+      </p:sp>
+      <p:pic>
+        <p:nvPicPr>
+          <p:cNvPr id="138" name="Picture 137" descr="dashboard.jpg"/>
+          <p:cNvPicPr>
+            <a:picLocks noChangeAspect="1"/>
+          </p:cNvPicPr>
+          <p:nvPr/>
+        </p:nvPicPr>
+        <p:blipFill>
+          <a:blip r:embed="rId5"/>
+          <a:stretch>
+            <a:fillRect/>
+          </a:stretch>
+        </p:blipFill>
+        <p:spPr>
+          <a:xfrm>
+            <a:off x="4654295" y="1207008"/>
+            <a:ext cx="4169663" cy="2606039"/>
+          </a:xfrm>
+          <a:prstGeom prst="rect">
+            <a:avLst/>
+          </a:prstGeom>
+          <a:ln w="9525">
+            <a:solidFill>
+              <a:srgbClr val="DADCE0"/>
+            </a:solidFill>
+          </a:ln>
+        </p:spPr>
+      </p:pic>
+      <p:sp>
+        <p:nvSpPr>
+          <p:cNvPr id="139" name="TextBox 138"/>
+          <p:cNvSpPr txBox="1"/>
+          <p:nvPr/>
+        </p:nvSpPr>
+        <p:spPr>
+          <a:xfrm>
+            <a:off x="4654295" y="3922776"/>
+            <a:ext cx="4169663" cy="822960"/>
+          </a:xfrm>
+          <a:prstGeom prst="rect">
+            <a:avLst/>
+          </a:prstGeom>
+          <a:noFill/>
+        </p:spPr>
+        <p:txBody>
+          <a:bodyPr wrap="square" anchor="t" lIns="0" rIns="0" tIns="0" bIns="0">
+            <a:spAutoFit/>
+          </a:bodyPr>
+          <a:lstStyle/>
+          <a:p>
+            <a:pPr algn="l">
+              <a:spcAft>
+                <a:spcPts val="300"/>
+              </a:spcAft>
+            </a:pPr>
+            <a:r>
+              <a:rPr sz="1000" i="0">
+                <a:solidFill>
+                  <a:srgbClr val="202124"/>
+                </a:solidFill>
+                <a:latin typeface="Google Sans Flex"/>
+              </a:rPr>
+              <a:t>Manager readiness view: who is ready to go live, weakest skills, top violations (sample team data, labeled in the app).</a:t>
+            </a:r>
+          </a:p>
+        </p:txBody>
+      </p:sp>
+    </p:spTree>
+  </p:cSld>
+  <p:clrMapOvr>
+    <a:masterClrMapping/>
+  </p:clrMapOvr>
+</p:sld>
+</file>
+
+<file path=ppt/slides/slide18.xml><?xml version="1.0" encoding="utf-8"?>
+<p:sld xmlns:a="http://schemas.openxmlformats.org/drawingml/2006/main" xmlns:p="http://schemas.openxmlformats.org/presentationml/2006/main" xmlns:r="http://schemas.openxmlformats.org/officeDocument/2006/relationships">
+  <p:cSld>
+    <p:spTree>
+      <p:nvGrpSpPr>
+        <p:cNvPr id="1" name=""/>
+        <p:cNvGrpSpPr/>
+        <p:nvPr/>
+      </p:nvGrpSpPr>
+      <p:grpSpPr/>
+      <p:pic>
+        <p:nvPicPr>
+          <p:cNvPr id="132" name="Google Shape;132;p23" title="Frame 144.png"/>
+          <p:cNvPicPr preferRelativeResize="0"/>
+          <p:nvPr/>
+        </p:nvPicPr>
+        <p:blipFill rotWithShape="1">
+          <a:blip r:embed="rId2">
+            <a:alphaModFix/>
+          </a:blip>
+          <a:srcRect b="98001" l="0" r="0" t="0"/>
+          <a:stretch/>
+        </p:blipFill>
+        <p:spPr>
+          <a:xfrm>
+            <a:off x="0" y="5093562"/>
+            <a:ext cx="9144000" cy="54275"/>
+          </a:xfrm>
+          <a:prstGeom prst="rect">
+            <a:avLst/>
+          </a:prstGeom>
+          <a:noFill/>
+          <a:ln>
+            <a:noFill/>
+          </a:ln>
+        </p:spPr>
+      </p:pic>
+      <p:pic>
+        <p:nvPicPr>
+          <p:cNvPr id="133" name="Google Shape;133;p23" title="Group 427319979.png"/>
+          <p:cNvPicPr preferRelativeResize="0"/>
+          <p:nvPr/>
+        </p:nvPicPr>
+        <p:blipFill>
+          <a:blip r:embed="rId3">
+            <a:alphaModFix/>
+          </a:blip>
+          <a:stretch>
+            <a:fillRect/>
+          </a:stretch>
+        </p:blipFill>
+        <p:spPr>
+          <a:xfrm>
+            <a:off x="0" y="1"/>
+            <a:ext cx="9144000" cy="507359"/>
+          </a:xfrm>
+          <a:prstGeom prst="rect">
+            <a:avLst/>
+          </a:prstGeom>
+          <a:noFill/>
+          <a:ln>
+            <a:noFill/>
+          </a:ln>
+        </p:spPr>
+      </p:pic>
+      <p:sp>
+        <p:nvSpPr>
+          <p:cNvPr id="134" name="Google Shape;134;p23"/>
+          <p:cNvSpPr/>
+          <p:nvPr/>
+        </p:nvSpPr>
+        <p:spPr>
+          <a:xfrm>
+            <a:off x="-29250" y="5071875"/>
+            <a:ext cx="9173400" cy="97800"/>
+          </a:xfrm>
+          <a:prstGeom prst="rect">
+            <a:avLst/>
+          </a:prstGeom>
+          <a:solidFill>
+            <a:schemeClr val="dk1"/>
+          </a:solidFill>
+          <a:ln>
+            <a:noFill/>
+          </a:ln>
+        </p:spPr>
+        <p:txBody>
+          <a:bodyPr anchorCtr="0" anchor="ctr" bIns="91425" lIns="91425" spcFirstLastPara="1" rIns="91425" wrap="square" tIns="91425">
+            <a:noAutofit/>
+          </a:bodyPr>
+          <a:lstStyle/>
+          <a:p>
+            <a:pPr indent="0" lvl="0" marL="0" rtl="0" algn="ctr">
+              <a:spcBef>
+                <a:spcPts val="0"/>
+              </a:spcBef>
+              <a:spcAft>
+                <a:spcPts val="0"/>
+              </a:spcAft>
+              <a:buNone/>
+            </a:pPr>
+            <a:r>
+              <a:t/>
+            </a:r>
+            <a:endParaRPr/>
+          </a:p>
+        </p:txBody>
+      </p:sp>
+      <p:sp>
+        <p:nvSpPr>
+          <p:cNvPr id="135" name="Google Shape;135;p23"/>
+          <p:cNvSpPr txBox="1"/>
+          <p:nvPr/>
+        </p:nvSpPr>
+        <p:spPr>
+          <a:xfrm>
+            <a:off x="265350" y="663825"/>
+            <a:ext cx="8943000" cy="457200"/>
+          </a:xfrm>
+          <a:prstGeom prst="rect">
+            <a:avLst/>
+          </a:prstGeom>
+          <a:noFill/>
+          <a:ln>
+            <a:noFill/>
+          </a:ln>
+        </p:spPr>
+        <p:txBody>
+          <a:bodyPr anchorCtr="0" anchor="t" bIns="91425" lIns="91425" spcFirstLastPara="1" rIns="91425" wrap="square" tIns="91425">
+            <a:noAutofit/>
+          </a:bodyPr>
+          <a:lstStyle/>
+          <a:p>
+            <a:pPr indent="0" lvl="0" marL="0" rtl="0" algn="l">
+              <a:spcBef>
+                <a:spcPts val="0"/>
+              </a:spcBef>
+              <a:spcAft>
+                <a:spcPts val="0"/>
+              </a:spcAft>
+              <a:buNone/>
+            </a:pPr>
+            <a:r>
+              <a:rPr lang="en-GB" sz="1600">
+                <a:latin typeface="Google Sans Flex Medium"/>
+                <a:ea typeface="Google Sans Flex Medium"/>
+                <a:cs typeface="Google Sans Flex Medium"/>
+                <a:sym typeface="Google Sans Flex Medium"/>
+              </a:rPr>
+              <a:t>Snapshots of the prototype: evidence</a:t>
+            </a:r>
+            <a:endParaRPr sz="1600">
+              <a:latin typeface="Google Sans Flex Medium"/>
+              <a:ea typeface="Google Sans Flex Medium"/>
+              <a:cs typeface="Google Sans Flex Medium"/>
+              <a:sym typeface="Google Sans Flex Medium"/>
+            </a:endParaRPr>
+          </a:p>
+        </p:txBody>
+      </p:sp>
+      <p:pic>
+        <p:nvPicPr>
+          <p:cNvPr id="136" name="Picture 135" descr="report_evidence.jpg"/>
+          <p:cNvPicPr>
+            <a:picLocks noChangeAspect="1"/>
+          </p:cNvPicPr>
+          <p:nvPr/>
+        </p:nvPicPr>
+        <p:blipFill>
+          <a:blip r:embed="rId4"/>
+          <a:stretch>
+            <a:fillRect/>
+          </a:stretch>
+        </p:blipFill>
+        <p:spPr>
+          <a:xfrm>
+            <a:off x="320040" y="1207008"/>
+            <a:ext cx="4169663" cy="2606039"/>
+          </a:xfrm>
+          <a:prstGeom prst="rect">
+            <a:avLst/>
+          </a:prstGeom>
+          <a:ln w="9525">
+            <a:solidFill>
+              <a:srgbClr val="DADCE0"/>
+            </a:solidFill>
+          </a:ln>
+        </p:spPr>
+      </p:pic>
+      <p:sp>
+        <p:nvSpPr>
+          <p:cNvPr id="137" name="TextBox 136"/>
+          <p:cNvSpPr txBox="1"/>
+          <p:nvPr/>
+        </p:nvSpPr>
+        <p:spPr>
+          <a:xfrm>
+            <a:off x="320040" y="3922776"/>
+            <a:ext cx="4169663" cy="822960"/>
+          </a:xfrm>
+          <a:prstGeom prst="rect">
+            <a:avLst/>
+          </a:prstGeom>
+          <a:noFill/>
+        </p:spPr>
+        <p:txBody>
+          <a:bodyPr wrap="square" anchor="t" lIns="0" rIns="0" tIns="0" bIns="0">
+            <a:spAutoFit/>
+          </a:bodyPr>
+          <a:lstStyle/>
+          <a:p>
+            <a:pPr algn="l">
+              <a:spcAft>
+                <a:spcPts val="300"/>
+              </a:spcAft>
+            </a:pPr>
+            <a:r>
+              <a:rPr sz="1000" i="0">
+                <a:solidFill>
+                  <a:srgbClr val="202124"/>
+                </a:solidFill>
+                <a:latin typeface="Google Sans Flex"/>
+              </a:rPr>
+              <a:t>Skills, with evidence: each score quotes the trainee's own words; select a quote to jump to that turn in the transcript.</a:t>
+            </a:r>
+          </a:p>
+        </p:txBody>
+      </p:sp>
+      <p:pic>
+        <p:nvPicPr>
+          <p:cNvPr id="138" name="Picture 137" descr="report_violations.jpg"/>
+          <p:cNvPicPr>
+            <a:picLocks noChangeAspect="1"/>
+          </p:cNvPicPr>
+          <p:nvPr/>
+        </p:nvPicPr>
+        <p:blipFill>
+          <a:blip r:embed="rId5"/>
+          <a:stretch>
+            <a:fillRect/>
+          </a:stretch>
+        </p:blipFill>
+        <p:spPr>
+          <a:xfrm>
+            <a:off x="4654295" y="1207008"/>
+            <a:ext cx="4169663" cy="2606039"/>
+          </a:xfrm>
+          <a:prstGeom prst="rect">
+            <a:avLst/>
+          </a:prstGeom>
+          <a:ln w="9525">
+            <a:solidFill>
+              <a:srgbClr val="DADCE0"/>
+            </a:solidFill>
+          </a:ln>
+        </p:spPr>
+      </p:pic>
+      <p:sp>
+        <p:nvSpPr>
+          <p:cNvPr id="139" name="TextBox 138"/>
+          <p:cNvSpPr txBox="1"/>
+          <p:nvPr/>
+        </p:nvSpPr>
+        <p:spPr>
+          <a:xfrm>
+            <a:off x="4654295" y="3922776"/>
+            <a:ext cx="4169663" cy="822960"/>
+          </a:xfrm>
+          <a:prstGeom prst="rect">
+            <a:avLst/>
+          </a:prstGeom>
+          <a:noFill/>
+        </p:spPr>
+        <p:txBody>
+          <a:bodyPr wrap="square" anchor="t" lIns="0" rIns="0" tIns="0" bIns="0">
+            <a:spAutoFit/>
+          </a:bodyPr>
+          <a:lstStyle/>
+          <a:p>
+            <a:pPr algn="l">
+              <a:spcAft>
+                <a:spcPts val="300"/>
+              </a:spcAft>
+            </a:pPr>
+            <a:r>
+              <a:rPr sz="1000" i="0">
+                <a:solidFill>
+                  <a:srgbClr val="202124"/>
+                </a:solidFill>
+                <a:latin typeface="Google Sans Flex"/>
+              </a:rPr>
+              <a:t>Compliance violations name the rule and the exact phrase; strengths and next steps turn the grade into a coaching plan.</a:t>
+            </a:r>
+          </a:p>
+        </p:txBody>
+      </p:sp>
+    </p:spTree>
+  </p:cSld>
+  <p:clrMapOvr>
+    <a:masterClrMapping/>
+  </p:clrMapOvr>
+</p:sld>
+</file>
+
+<file path=ppt/slides/slide19.xml><?xml version="1.0" encoding="utf-8"?>
+<p:sld xmlns:a="http://schemas.openxmlformats.org/drawingml/2006/main" xmlns:p="http://schemas.openxmlformats.org/presentationml/2006/main" xmlns:r="http://schemas.openxmlformats.org/officeDocument/2006/relationships">
+  <p:cSld>
+    <p:spTree>
+      <p:nvGrpSpPr>
+        <p:cNvPr id="1" name=""/>
+        <p:cNvGrpSpPr/>
+        <p:nvPr/>
+      </p:nvGrpSpPr>
+      <p:grpSpPr/>
+      <p:pic>
+        <p:nvPicPr>
+          <p:cNvPr id="132" name="Google Shape;132;p23" title="Frame 144.png"/>
+          <p:cNvPicPr preferRelativeResize="0"/>
+          <p:nvPr/>
+        </p:nvPicPr>
+        <p:blipFill rotWithShape="1">
+          <a:blip r:embed="rId2">
+            <a:alphaModFix/>
+          </a:blip>
+          <a:srcRect b="98001" l="0" r="0" t="0"/>
+          <a:stretch/>
+        </p:blipFill>
+        <p:spPr>
+          <a:xfrm>
+            <a:off x="0" y="5093562"/>
+            <a:ext cx="9144000" cy="54275"/>
+          </a:xfrm>
+          <a:prstGeom prst="rect">
+            <a:avLst/>
+          </a:prstGeom>
+          <a:noFill/>
+          <a:ln>
+            <a:noFill/>
+          </a:ln>
+        </p:spPr>
+      </p:pic>
+      <p:pic>
+        <p:nvPicPr>
+          <p:cNvPr id="133" name="Google Shape;133;p23" title="Group 427319979.png"/>
+          <p:cNvPicPr preferRelativeResize="0"/>
+          <p:nvPr/>
+        </p:nvPicPr>
+        <p:blipFill>
+          <a:blip r:embed="rId3">
+            <a:alphaModFix/>
+          </a:blip>
+          <a:stretch>
+            <a:fillRect/>
+          </a:stretch>
+        </p:blipFill>
+        <p:spPr>
+          <a:xfrm>
+            <a:off x="0" y="1"/>
+            <a:ext cx="9144000" cy="507359"/>
+          </a:xfrm>
+          <a:prstGeom prst="rect">
+            <a:avLst/>
+          </a:prstGeom>
+          <a:noFill/>
+          <a:ln>
+            <a:noFill/>
+          </a:ln>
+        </p:spPr>
+      </p:pic>
+      <p:sp>
+        <p:nvSpPr>
+          <p:cNvPr id="134" name="Google Shape;134;p23"/>
+          <p:cNvSpPr/>
+          <p:nvPr/>
+        </p:nvSpPr>
+        <p:spPr>
+          <a:xfrm>
+            <a:off x="-29250" y="5071875"/>
+            <a:ext cx="9173400" cy="97800"/>
+          </a:xfrm>
+          <a:prstGeom prst="rect">
+            <a:avLst/>
+          </a:prstGeom>
+          <a:solidFill>
+            <a:schemeClr val="dk1"/>
+          </a:solidFill>
+          <a:ln>
+            <a:noFill/>
+          </a:ln>
+        </p:spPr>
+        <p:txBody>
+          <a:bodyPr anchorCtr="0" anchor="ctr" bIns="91425" lIns="91425" spcFirstLastPara="1" rIns="91425" wrap="square" tIns="91425">
+            <a:noAutofit/>
+          </a:bodyPr>
+          <a:lstStyle/>
+          <a:p>
+            <a:pPr indent="0" lvl="0" marL="0" rtl="0" algn="ctr">
+              <a:spcBef>
+                <a:spcPts val="0"/>
+              </a:spcBef>
+              <a:spcAft>
+                <a:spcPts val="0"/>
+              </a:spcAft>
+              <a:buNone/>
+            </a:pPr>
+            <a:r>
+              <a:t/>
+            </a:r>
+            <a:endParaRPr/>
+          </a:p>
+        </p:txBody>
+      </p:sp>
+      <p:sp>
+        <p:nvSpPr>
+          <p:cNvPr id="135" name="Google Shape;135;p23"/>
+          <p:cNvSpPr txBox="1"/>
+          <p:nvPr/>
+        </p:nvSpPr>
+        <p:spPr>
+          <a:xfrm>
+            <a:off x="265350" y="663825"/>
+            <a:ext cx="8943000" cy="457200"/>
+          </a:xfrm>
+          <a:prstGeom prst="rect">
+            <a:avLst/>
+          </a:prstGeom>
+          <a:noFill/>
+          <a:ln>
+            <a:noFill/>
+          </a:ln>
+        </p:spPr>
+        <p:txBody>
+          <a:bodyPr anchorCtr="0" anchor="t" bIns="91425" lIns="91425" spcFirstLastPara="1" rIns="91425" wrap="square" tIns="91425">
+            <a:noAutofit/>
+          </a:bodyPr>
+          <a:lstStyle/>
+          <a:p>
+            <a:pPr indent="0" lvl="0" marL="0" rtl="0" algn="l">
+              <a:spcBef>
+                <a:spcPts val="0"/>
+              </a:spcBef>
+              <a:spcAft>
+                <a:spcPts val="0"/>
+              </a:spcAft>
+              <a:buNone/>
+            </a:pPr>
+            <a:r>
+              <a:rPr lang="en-GB" sz="1600">
+                <a:latin typeface="Google Sans Flex Medium"/>
+                <a:ea typeface="Google Sans Flex Medium"/>
+                <a:cs typeface="Google Sans Flex Medium"/>
+                <a:sym typeface="Google Sans Flex Medium"/>
+              </a:rPr>
+              <a:t>Snapshots of the prototype: coaching and the report</a:t>
+            </a:r>
+            <a:endParaRPr sz="1600">
+              <a:latin typeface="Google Sans Flex Medium"/>
+              <a:ea typeface="Google Sans Flex Medium"/>
+              <a:cs typeface="Google Sans Flex Medium"/>
+              <a:sym typeface="Google Sans Flex Medium"/>
+            </a:endParaRPr>
+          </a:p>
+        </p:txBody>
+      </p:sp>
+      <p:pic>
+        <p:nvPicPr>
+          <p:cNvPr id="136" name="Picture 135" descr="practice_session.jpg"/>
+          <p:cNvPicPr>
+            <a:picLocks noChangeAspect="1"/>
+          </p:cNvPicPr>
+          <p:nvPr/>
+        </p:nvPicPr>
+        <p:blipFill>
+          <a:blip r:embed="rId4"/>
+          <a:stretch>
+            <a:fillRect/>
+          </a:stretch>
+        </p:blipFill>
+        <p:spPr>
+          <a:xfrm>
+            <a:off x="320040" y="1207008"/>
+            <a:ext cx="4169663" cy="2606039"/>
+          </a:xfrm>
+          <a:prstGeom prst="rect">
+            <a:avLst/>
+          </a:prstGeom>
+          <a:ln w="9525">
+            <a:solidFill>
+              <a:srgbClr val="DADCE0"/>
+            </a:solidFill>
+          </a:ln>
+        </p:spPr>
+      </p:pic>
+      <p:sp>
+        <p:nvSpPr>
+          <p:cNvPr id="137" name="TextBox 136"/>
+          <p:cNvSpPr txBox="1"/>
+          <p:nvPr/>
+        </p:nvSpPr>
+        <p:spPr>
+          <a:xfrm>
+            <a:off x="320040" y="3922776"/>
+            <a:ext cx="4169663" cy="822960"/>
+          </a:xfrm>
+          <a:prstGeom prst="rect">
+            <a:avLst/>
+          </a:prstGeom>
+          <a:noFill/>
+        </p:spPr>
+        <p:txBody>
+          <a:bodyPr wrap="square" anchor="t" lIns="0" rIns="0" tIns="0" bIns="0">
+            <a:spAutoFit/>
+          </a:bodyPr>
+          <a:lstStyle/>
+          <a:p>
+            <a:pPr algn="l">
+              <a:spcAft>
+                <a:spcPts val="300"/>
+              </a:spcAft>
+            </a:pPr>
+            <a:r>
+              <a:rPr sz="1000" i="0">
+                <a:solidFill>
+                  <a:srgbClr val="202124"/>
+                </a:solidFill>
+                <a:latin typeface="Google Sans Flex"/>
+              </a:rPr>
+              <a:t>Later in the session: trust has dropped, the coach suggests the next move, and every customer reply cites the knowledge base.</a:t>
+            </a:r>
+          </a:p>
+        </p:txBody>
+      </p:sp>
+      <p:pic>
+        <p:nvPicPr>
+          <p:cNvPr id="138" name="Picture 137" descr="report.jpg"/>
+          <p:cNvPicPr>
+            <a:picLocks noChangeAspect="1"/>
+          </p:cNvPicPr>
+          <p:nvPr/>
+        </p:nvPicPr>
+        <p:blipFill>
+          <a:blip r:embed="rId5"/>
+          <a:stretch>
+            <a:fillRect/>
+          </a:stretch>
+        </p:blipFill>
+        <p:spPr>
+          <a:xfrm>
+            <a:off x="4654295" y="1207008"/>
+            <a:ext cx="4169663" cy="2606039"/>
+          </a:xfrm>
+          <a:prstGeom prst="rect">
+            <a:avLst/>
+          </a:prstGeom>
+          <a:ln w="9525">
+            <a:solidFill>
+              <a:srgbClr val="DADCE0"/>
+            </a:solidFill>
+          </a:ln>
+        </p:spPr>
+      </p:pic>
+      <p:sp>
+        <p:nvSpPr>
+          <p:cNvPr id="139" name="TextBox 138"/>
+          <p:cNvSpPr txBox="1"/>
+          <p:nvPr/>
+        </p:nvSpPr>
+        <p:spPr>
+          <a:xfrm>
+            <a:off x="4654295" y="3922776"/>
+            <a:ext cx="4169663" cy="822960"/>
+          </a:xfrm>
+          <a:prstGeom prst="rect">
+            <a:avLst/>
+          </a:prstGeom>
+          <a:noFill/>
+        </p:spPr>
+        <p:txBody>
+          <a:bodyPr wrap="square" anchor="t" lIns="0" rIns="0" tIns="0" bIns="0">
+            <a:spAutoFit/>
+          </a:bodyPr>
+          <a:lstStyle/>
+          <a:p>
+            <a:pPr algn="l">
+              <a:spcAft>
+                <a:spcPts val="300"/>
+              </a:spcAft>
+            </a:pPr>
+            <a:r>
+              <a:rPr sz="1000" i="0">
+                <a:solidFill>
+                  <a:srgbClr val="202124"/>
+                </a:solidFill>
+                <a:latin typeface="Google Sans Flex"/>
+              </a:rPr>
+              <a:t>The report: one high-severity violation fails the compliance gate and caps the score (28 here), however good the rest was.</a:t>
+            </a:r>
+          </a:p>
+        </p:txBody>
+      </p:sp>
+    </p:spTree>
+  </p:cSld>
+  <p:clrMapOvr>
+    <a:masterClrMapping/>
+  </p:clrMapOvr>
+</p:sld>
+</file>
+
 <file path=ppt/slides/slide3.xml><?xml version="1.0" encoding="utf-8"?>
 <p:sld xmlns:a="http://schemas.openxmlformats.org/drawingml/2006/main" xmlns:r="http://schemas.openxmlformats.org/officeDocument/2006/relationships" xmlns:mc="http://schemas.openxmlformats.org/markup-compatibility/2006" xmlns:mv="urn:schemas-microsoft-com:mac:vml" xmlns:p="http://schemas.openxmlformats.org/presentationml/2006/main" xmlns:c="http://schemas.openxmlformats.org/drawingml/2006/chart" xmlns:dgm="http://schemas.openxmlformats.org/drawingml/2006/diagram" xmlns:o="urn:schemas-microsoft-com:office:office" xmlns:v="urn:schemas-microsoft-com:vml" xmlns:pvml="urn:schemas-microsoft-com:office:powerpoint" xmlns:com="http://schemas.openxmlformats.org/drawingml/2006/compatibility" xmlns:p14="http://schemas.microsoft.com/office/powerpoint/2010/main" xmlns:p15="http://schemas.microsoft.com/office/powerpoint/2012/main" xmlns:ahyp="http://schemas.microsoft.com/office/drawing/2018/hyperlinkcolor">
   <p:cSld>
@@ -13901,14 +14680,14 @@
                 </a:solidFill>
                 <a:latin typeface="Google Sans Flex SemiBold"/>
               </a:rPr>
-              <a:t>Live app: the Compliance Guard holds a risky message</a:t>
+              <a:t>Live app: a 3D customer, and the Guard holds a risky message</a:t>
             </a:r>
           </a:p>
         </p:txBody>
       </p:sp>
       <p:pic>
         <p:nvPicPr>
-          <p:cNvPr id="83" name="Picture 82" descr="crop_guard_full.png"/>
+          <p:cNvPr id="83" name="Picture 82" descr="practice_guard.jpg"/>
           <p:cNvPicPr>
             <a:picLocks noChangeAspect="1"/>
           </p:cNvPicPr>
@@ -13922,8 +14701,8 @@
         </p:blipFill>
         <p:spPr>
           <a:xfrm>
-            <a:off x="5394960" y="1679705"/>
-            <a:ext cx="3291840" cy="2026405"/>
+            <a:off x="5394960" y="1664208"/>
+            <a:ext cx="3291840" cy="2057400"/>
           </a:xfrm>
           <a:prstGeom prst="rect">
             <a:avLst/>
@@ -13969,7 +14748,7 @@
                 </a:solidFill>
                 <a:latin typeface="Google Sans Flex"/>
               </a:rPr>
-              <a:t>The trainee types a guaranteed-return promise. The Guard quotes the phrase, names rule CC-01 and offers Edit message or Send anyway.</a:t>
+              <a:t>Mr. Tan, a cautious retiree, is rendered as a 3D customer. The trainee types a guaranteed-return promise; the Guard quotes the phrase, names rule CC-01 and offers Edit message or Send anyway.</a:t>
             </a:r>
           </a:p>
         </p:txBody>
@@ -16792,7 +17571,7 @@
       </p:sp>
       <p:pic>
         <p:nvPicPr>
-          <p:cNvPr id="99" name="Picture 98" descr="crop_persona_cite.png"/>
+          <p:cNvPr id="99" name="Picture 98" descr="persona_detail.jpg"/>
           <p:cNvPicPr>
             <a:picLocks noChangeAspect="1"/>
           </p:cNvPicPr>
@@ -16806,8 +17585,8 @@
         </p:blipFill>
         <p:spPr>
           <a:xfrm>
-            <a:off x="421450" y="1645920"/>
-            <a:ext cx="2375786" cy="1463040"/>
+            <a:off x="438911" y="1645919"/>
+            <a:ext cx="2340864" cy="1463040"/>
           </a:xfrm>
           <a:prstGeom prst="rect">
             <a:avLst/>
@@ -17078,7 +17857,7 @@
       </p:sp>
       <p:pic>
         <p:nvPicPr>
-          <p:cNvPr id="105" name="Picture 104" descr="crop_guard.png"/>
+          <p:cNvPr id="105" name="Picture 104" descr="practice_guard.jpg"/>
           <p:cNvPicPr>
             <a:picLocks noChangeAspect="1"/>
           </p:cNvPicPr>
@@ -17092,8 +17871,8 @@
         </p:blipFill>
         <p:spPr>
           <a:xfrm>
-            <a:off x="3383834" y="1645920"/>
-            <a:ext cx="2376331" cy="1463040"/>
+            <a:off x="3401568" y="1645919"/>
+            <a:ext cx="2340864" cy="1463040"/>
           </a:xfrm>
           <a:prstGeom prst="rect">
             <a:avLst/>
@@ -17364,7 +18143,7 @@
       </p:sp>
       <p:pic>
         <p:nvPicPr>
-          <p:cNvPr id="111" name="Picture 110" descr="crop_dashboard_top.png"/>
+          <p:cNvPr id="111" name="Picture 110" descr="report.jpg"/>
           <p:cNvPicPr>
             <a:picLocks noChangeAspect="1"/>
           </p:cNvPicPr>
@@ -17378,8 +18157,8 @@
         </p:blipFill>
         <p:spPr>
           <a:xfrm>
-            <a:off x="6346652" y="1645920"/>
-            <a:ext cx="2376007" cy="1463040"/>
+            <a:off x="6364223" y="1645919"/>
+            <a:ext cx="2340864" cy="1463040"/>
           </a:xfrm>
           <a:prstGeom prst="rect">
             <a:avLst/>
@@ -17499,7 +18278,7 @@
                 </a:solidFill>
                 <a:latin typeface="Google Sans Flex"/>
               </a:rPr>
-              <a:t>Screens from the deployed app: persona draft with citation chips, Compliance Guard card, manager readiness view (sample team data, labeled in the app).</a:t>
+              <a:t>Screens from the deployed app: a persona grounded in cited sources, the 3D customer with the Compliance Guard card, and the evidence-verified report.</a:t>
             </a:r>
           </a:p>
         </p:txBody>
@@ -17681,7 +18460,7 @@
       </p:sp>
       <p:pic>
         <p:nvPicPr>
-          <p:cNvPr id="104" name="Picture 103" descr="home.png"/>
+          <p:cNvPr id="104" name="Picture 103" descr="home.jpg"/>
           <p:cNvPicPr>
             <a:picLocks noChangeAspect="1"/>
           </p:cNvPicPr>
@@ -17695,8 +18474,8 @@
         </p:blipFill>
         <p:spPr>
           <a:xfrm>
-            <a:off x="974343" y="1207007"/>
-            <a:ext cx="2861056" cy="1609344"/>
+            <a:off x="1117396" y="1207008"/>
+            <a:ext cx="2574950" cy="1609344"/>
           </a:xfrm>
           <a:prstGeom prst="rect">
             <a:avLst/>
@@ -17742,14 +18521,14 @@
                 </a:solidFill>
                 <a:latin typeface="Google Sans Flex"/>
               </a:rPr>
-              <a:t>Home: pick a scenario and start practicing</a:t>
+              <a:t>Home: what SkillCoach does, start the 3-minute demo</a:t>
             </a:r>
           </a:p>
         </p:txBody>
       </p:sp>
       <p:pic>
         <p:nvPicPr>
-          <p:cNvPr id="106" name="Picture 105" descr="knowledge.png"/>
+          <p:cNvPr id="106" name="Picture 105" descr="knowledge.jpg"/>
           <p:cNvPicPr>
             <a:picLocks noChangeAspect="1"/>
           </p:cNvPicPr>
@@ -17763,8 +18542,8 @@
         </p:blipFill>
         <p:spPr>
           <a:xfrm>
-            <a:off x="5308599" y="1207007"/>
-            <a:ext cx="2861056" cy="1609344"/>
+            <a:off x="5451652" y="1207008"/>
+            <a:ext cx="2574950" cy="1609344"/>
           </a:xfrm>
           <a:prstGeom prst="rect">
             <a:avLst/>
@@ -17810,14 +18589,14 @@
                 </a:solidFill>
                 <a:latin typeface="Google Sans Flex"/>
               </a:rPr>
-              <a:t>Knowledge base: upload manuals and policies</a:t>
+              <a:t>Knowledge base: upload manuals and policies, test a search</a:t>
             </a:r>
           </a:p>
         </p:txBody>
       </p:sp>
       <p:pic>
         <p:nvPicPr>
-          <p:cNvPr id="108" name="Picture 107" descr="personas.png"/>
+          <p:cNvPr id="108" name="Picture 107" descr="persona_new.jpg"/>
           <p:cNvPicPr>
             <a:picLocks noChangeAspect="1"/>
           </p:cNvPicPr>
@@ -17831,8 +18610,8 @@
         </p:blipFill>
         <p:spPr>
           <a:xfrm>
-            <a:off x="974343" y="3127248"/>
-            <a:ext cx="2861056" cy="1609344"/>
+            <a:off x="1117396" y="3127248"/>
+            <a:ext cx="2574950" cy="1609344"/>
           </a:xfrm>
           <a:prstGeom prst="rect">
             <a:avLst/>
@@ -17878,14 +18657,14 @@
                 </a:solidFill>
                 <a:latin typeface="Google Sans Flex"/>
               </a:rPr>
-              <a:t>Personas: drafts and approved customers</a:t>
+              <a:t>Persona builder: describe, generate from documents, or fill in</a:t>
             </a:r>
           </a:p>
         </p:txBody>
       </p:sp>
       <p:pic>
         <p:nvPicPr>
-          <p:cNvPr id="110" name="Picture 109" descr="scenario_detail.png"/>
+          <p:cNvPr id="110" name="Picture 109" descr="scenarios.jpg"/>
           <p:cNvPicPr>
             <a:picLocks noChangeAspect="1"/>
           </p:cNvPicPr>
@@ -17899,8 +18678,8 @@
         </p:blipFill>
         <p:spPr>
           <a:xfrm>
-            <a:off x="5308599" y="3127248"/>
-            <a:ext cx="2861056" cy="1609344"/>
+            <a:off x="5451652" y="3127248"/>
+            <a:ext cx="2574950" cy="1609344"/>
           </a:xfrm>
           <a:prstGeom prst="rect">
             <a:avLst/>
@@ -17946,7 +18725,7 @@
                 </a:solidFill>
                 <a:latin typeface="Google Sans Flex"/>
               </a:rPr>
-              <a:t>Scenario: goal, rules and rubric with citations</a:t>
+              <a:t>Scenarios: one customer, rubric and rules each</a:t>
             </a:r>
           </a:p>
         </p:txBody>

</xml_diff>

<commit_message>
Live call mode: camera, hands-free voice, Gemini delivery feedback
- Practice screen gets a "Live call (camera + voice)" switch: the
  trainee's camera shows picture-in-picture on the 3D customer, the mic
  reopens whenever it is the trainee's turn, a finished utterance is
  sent automatically and the reply is spoken back.
- POST /api/sessions/{id}/delivery: Gemini 3.5 Flash-Lite reviews one
  webcam frame per turn for eye contact, expression and posture and
  returns one tip. Frames are validated, never stored, and the prompt
  forbids comments on appearance or identity.
- Tests for the delivery agent and route; docs, deck and submission
  brief describe the feature.

Co-Authored-By: Claude Opus 5.5 <noreply@anthropic.com>
</commit_message>
<xml_diff>
--- a/media/SkillCoach_Submission.pptx
+++ b/media/SkillCoach_Submission.pptx
@@ -10475,7 +10475,7 @@
                 </a:solidFill>
                 <a:latin typeface="Google Sans Flex"/>
               </a:rPr>
-              <a:t>Text practice with a 3D AI customer</a:t>
+              <a:t>Practice with a 3D AI customer</a:t>
             </a:r>
           </a:p>
           <a:p>
@@ -10492,7 +10492,7 @@
                 </a:solidFill>
                 <a:latin typeface="Google Sans Flex"/>
               </a:rPr>
-              <a:t>Browser voice: speech input, spoken replies</a:t>
+              <a:t>Live call: camera, hands-free voice, delivery feedback</a:t>
             </a:r>
           </a:p>
           <a:p>
@@ -17203,7 +17203,7 @@
                 </a:solidFill>
                 <a:latin typeface="Google Sans Flex SemiBold"/>
               </a:rPr>
-              <a:t>3D customer and voice</a:t>
+              <a:t>Live video call</a:t>
             </a:r>
           </a:p>
         </p:txBody>
@@ -17242,7 +17242,7 @@
                 </a:solidFill>
                 <a:latin typeface="Google Sans Flex"/>
               </a:rPr>
-              <a:t>A 3D customer that lip-syncs, blinks and shows its mood from the trust meter; speech input and spoken replies.</a:t>
+              <a:t>Camera on, hands-free voice with a 3D customer that lip-syncs and shows its mood; Gemini reviews eye contact and expression.</a:t>
             </a:r>
           </a:p>
         </p:txBody>
@@ -20867,7 +20867,7 @@
         </p:nvGraphicFramePr>
         <p:xfrm>
           <a:off x="320040" y="1207008"/>
-          <a:ext cx="5394960" cy="2633472"/>
+          <a:ext cx="5394960" cy="2798064"/>
         </p:xfrm>
         <a:graphic>
           <a:graphicData uri="http://schemas.openxmlformats.org/drawingml/2006/table">
@@ -20880,7 +20880,7 @@
                 <a:gridCol w="1097280"/>
                 <a:gridCol w="2514600"/>
               </a:tblGrid>
-              <a:tr h="329184">
+              <a:tr h="310896">
                 <a:tc>
                   <a:txBody>
                     <a:bodyPr wrap="square"/>
@@ -20948,7 +20948,7 @@
                   </a:tcPr>
                 </a:tc>
               </a:tr>
-              <a:tr h="329184">
+              <a:tr h="310896">
                 <a:tc>
                   <a:txBody>
                     <a:bodyPr wrap="square"/>
@@ -21016,7 +21016,7 @@
                   </a:tcPr>
                 </a:tc>
               </a:tr>
-              <a:tr h="329184">
+              <a:tr h="310896">
                 <a:tc>
                   <a:txBody>
                     <a:bodyPr wrap="square"/>
@@ -21084,7 +21084,7 @@
                   </a:tcPr>
                 </a:tc>
               </a:tr>
-              <a:tr h="329184">
+              <a:tr h="310896">
                 <a:tc>
                   <a:txBody>
                     <a:bodyPr wrap="square"/>
@@ -21152,7 +21152,7 @@
                   </a:tcPr>
                 </a:tc>
               </a:tr>
-              <a:tr h="329184">
+              <a:tr h="310896">
                 <a:tc>
                   <a:txBody>
                     <a:bodyPr wrap="square"/>
@@ -21220,7 +21220,7 @@
                   </a:tcPr>
                 </a:tc>
               </a:tr>
-              <a:tr h="329184">
+              <a:tr h="310896">
                 <a:tc>
                   <a:txBody>
                     <a:bodyPr wrap="square"/>
@@ -21288,7 +21288,7 @@
                   </a:tcPr>
                 </a:tc>
               </a:tr>
-              <a:tr h="329184">
+              <a:tr h="310896">
                 <a:tc>
                   <a:txBody>
                     <a:bodyPr wrap="square"/>
@@ -21356,7 +21356,7 @@
                   </a:tcPr>
                 </a:tc>
               </a:tr>
-              <a:tr h="329184">
+              <a:tr h="310896">
                 <a:tc>
                   <a:txBody>
                     <a:bodyPr wrap="square"/>
@@ -21424,6 +21424,74 @@
                   </a:tcPr>
                 </a:tc>
               </a:tr>
+              <a:tr h="310896">
+                <a:tc>
+                  <a:txBody>
+                    <a:bodyPr wrap="square"/>
+                    <a:lstStyle/>
+                    <a:p>
+                      <a:r>
+                        <a:rPr sz="850" i="0">
+                          <a:solidFill>
+                            <a:srgbClr val="202124"/>
+                          </a:solidFill>
+                          <a:latin typeface="Google Sans Flex SemiBold"/>
+                        </a:rPr>
+                        <a:t>Delivery coach (live, vision)</a:t>
+                      </a:r>
+                    </a:p>
+                  </a:txBody>
+                  <a:tcPr marL="54864" marR="54864" marT="27432" marB="27432" anchor="ctr">
+                    <a:solidFill>
+                      <a:srgbClr val="F1F3F4"/>
+                    </a:solidFill>
+                  </a:tcPr>
+                </a:tc>
+                <a:tc>
+                  <a:txBody>
+                    <a:bodyPr wrap="square"/>
+                    <a:lstStyle/>
+                    <a:p>
+                      <a:r>
+                        <a:rPr sz="850" i="0">
+                          <a:solidFill>
+                            <a:srgbClr val="188038"/>
+                          </a:solidFill>
+                          <a:latin typeface="Google Sans Flex SemiBold"/>
+                        </a:rPr>
+                        <a:t>3.5 Flash-Lite</a:t>
+                      </a:r>
+                    </a:p>
+                  </a:txBody>
+                  <a:tcPr marL="54864" marR="54864" marT="27432" marB="27432" anchor="ctr">
+                    <a:solidFill>
+                      <a:srgbClr val="F1F3F4"/>
+                    </a:solidFill>
+                  </a:tcPr>
+                </a:tc>
+                <a:tc>
+                  <a:txBody>
+                    <a:bodyPr wrap="square"/>
+                    <a:lstStyle/>
+                    <a:p>
+                      <a:r>
+                        <a:rPr sz="850" i="0">
+                          <a:solidFill>
+                            <a:srgbClr val="202124"/>
+                          </a:solidFill>
+                          <a:latin typeface="Google Sans Flex"/>
+                        </a:rPr>
+                        <a:t>One camera frame per turn, not stored; no comments on looks</a:t>
+                      </a:r>
+                    </a:p>
+                  </a:txBody>
+                  <a:tcPr marL="54864" marR="54864" marT="27432" marB="27432" anchor="ctr">
+                    <a:solidFill>
+                      <a:srgbClr val="F1F3F4"/>
+                    </a:solidFill>
+                  </a:tcPr>
+                </a:tc>
+              </a:tr>
             </a:tbl>
           </a:graphicData>
         </a:graphic>
@@ -21570,7 +21638,7 @@
                 </a:solidFill>
                 <a:latin typeface="Google Sans Flex"/>
               </a:rPr>
-              <a:t>seven agent roles via Vertex AI (google-genai SDK), structured JSON output, streaming, embeddings.</a:t>
+              <a:t>seven agent roles via Vertex AI (google-genai SDK), plus a vision check in live calls; structured JSON, streaming, embeddings.</a:t>
             </a:r>
           </a:p>
           <a:p>

</xml_diff>

<commit_message>
Deck and demo video refresh: video customers, live call, voices, new design
Co-Authored-By: Claude Opus 5.5 <noreply@anthropic.com>
</commit_message>
<xml_diff>
--- a/media/SkillCoach_Submission.pptx
+++ b/media/SkillCoach_Submission.pptx
@@ -8453,7 +8453,7 @@
       </p:sp>
       <p:pic>
         <p:nvPicPr>
-          <p:cNvPr id="136" name="Picture 135" descr="practice_start.jpg"/>
+          <p:cNvPr id="136" name="Picture 135" descr="practice_live.jpg"/>
           <p:cNvPicPr>
             <a:picLocks noChangeAspect="1"/>
           </p:cNvPicPr>
@@ -8514,7 +8514,7 @@
                 </a:solidFill>
                 <a:latin typeface="Google Sans Flex"/>
               </a:rPr>
-              <a:t>Mr. Tan as a 3D customer: he blinks, breathes, keeps eye contact and lip-syncs. His mood follows the trust and patience meters.</a:t>
+              <a:t>A live call: Mr. Tan, animated with Veo, listens, talks and frowns as trust changes; the trainee's camera joins with a virtual background and on-device expression tracking.</a:t>
             </a:r>
           </a:p>
         </p:txBody>
@@ -10475,7 +10475,7 @@
                 </a:solidFill>
                 <a:latin typeface="Google Sans Flex"/>
               </a:rPr>
-              <a:t>Practice with a 3D AI customer</a:t>
+              <a:t>Lifelike video customers (Gemini image + Veo)</a:t>
             </a:r>
           </a:p>
           <a:p>
@@ -10702,7 +10702,7 @@
                 </a:solidFill>
                 <a:latin typeface="Google Sans Flex"/>
               </a:rPr>
-              <a:t>On-device emotion cues</a:t>
+              <a:t>Delivery trends in the report</a:t>
             </a:r>
           </a:p>
           <a:p>
@@ -14025,7 +14025,7 @@
                 </a:solidFill>
                 <a:latin typeface="Google Sans Flex"/>
               </a:rPr>
-              <a:t>The report: one high-severity violation fails the compliance gate and caps the score (28 here), however good the rest was.</a:t>
+              <a:t>The report: one high-severity violation fails the compliance gate and caps the score (37 in this recorded session), however good the rest was.</a:t>
             </a:r>
           </a:p>
         </p:txBody>
@@ -14409,7 +14409,7 @@
                 </a:solidFill>
                 <a:latin typeface="Google Sans Flex"/>
               </a:rPr>
-              <a:t>Upload manuals and policies; Gemini drafts realistic AI customers that cite the source passages. A trainer approves them, and trainees practice any time with a 3D customer and a coach on every turn.</a:t>
+              <a:t>Upload manuals and policies; Gemini drafts realistic AI customers that cite the source passages. A trainer approves them, and trainees practice any time with a lifelike video customer and a coach on every turn.</a:t>
             </a:r>
           </a:p>
         </p:txBody>
@@ -14680,7 +14680,7 @@
                 </a:solidFill>
                 <a:latin typeface="Google Sans Flex SemiBold"/>
               </a:rPr>
-              <a:t>Live app: a 3D customer, and the Guard holds a risky message</a:t>
+              <a:t>Live app: a video-call customer, and the Guard holds a risky message</a:t>
             </a:r>
           </a:p>
         </p:txBody>
@@ -14748,7 +14748,7 @@
                 </a:solidFill>
                 <a:latin typeface="Google Sans Flex"/>
               </a:rPr>
-              <a:t>Mr. Tan, a cautious retiree, is rendered as a 3D customer. The trainee types a guaranteed-return promise; the Guard quotes the phrase, names rule CC-01 and offers Edit message or Send anyway.</a:t>
+              <a:t>Mr. Tan is a fictional retiree made with Gemini image generation and Veo. The trainee types a guaranteed-return promise; the Guard quotes the phrase, names rule CC-01 and offers Edit message or Send anyway.</a:t>
             </a:r>
           </a:p>
         </p:txBody>
@@ -16153,7 +16153,7 @@
                 </a:solidFill>
                 <a:latin typeface="Google Sans Flex SemiBold"/>
               </a:rPr>
-              <a:t>Live AI customer</a:t>
+              <a:t>Lifelike AI customer</a:t>
             </a:r>
           </a:p>
         </p:txBody>
@@ -16192,7 +16192,7 @@
                 </a:solidFill>
                 <a:latin typeface="Google Sans Flex"/>
               </a:rPr>
-              <a:t>Streamed replies, hidden needs revealed only when trust is earned, facts limited to the knowledge base.</a:t>
+              <a:t>A Veo-animated person on a video call; streamed replies, hidden needs revealed only when trust is earned.</a:t>
             </a:r>
           </a:p>
         </p:txBody>
@@ -17242,7 +17242,7 @@
                 </a:solidFill>
                 <a:latin typeface="Google Sans Flex"/>
               </a:rPr>
-              <a:t>Camera on, hands-free voice with a 3D customer that lip-syncs and shows its mood; Gemini reviews eye contact and expression.</a:t>
+              <a:t>Camera with background blur or virtual backgrounds, hands-free voice, on-device emotion and eye-contact tracking, Gemini delivery tips.</a:t>
             </a:r>
           </a:p>
         </p:txBody>
@@ -18278,7 +18278,7 @@
                 </a:solidFill>
                 <a:latin typeface="Google Sans Flex"/>
               </a:rPr>
-              <a:t>Screens from the deployed app: a persona grounded in cited sources, the 3D customer with the Compliance Guard card, and the evidence-verified report.</a:t>
+              <a:t>Screens from the deployed app: a persona grounded in cited sources, the video customer with the Compliance Guard card, and the evidence-verified report.</a:t>
             </a:r>
           </a:p>
         </p:txBody>
@@ -21713,7 +21713,7 @@
                 </a:solidFill>
                 <a:latin typeface="Google Sans Flex"/>
               </a:rPr>
-              <a:t>Hosting serves the public URL and rewrites traffic to Cloud Run.</a:t>
+              <a:t>Hosting serves the public URL; Authentication handles sign-up, sign-in and guests.</a:t>
             </a:r>
           </a:p>
           <a:p>
@@ -21729,6 +21729,31 @@
                 </a:solidFill>
                 <a:latin typeface="Google Sans Flex SemiBold"/>
               </a:rPr>
+              <a:t>Veo + Gemini image: </a:t>
+            </a:r>
+            <a:r>
+              <a:rPr sz="950" i="0">
+                <a:solidFill>
+                  <a:srgbClr val="202124"/>
+                </a:solidFill>
+                <a:latin typeface="Google Sans Flex"/>
+              </a:rPr>
+              <a:t>fictional customer portraits animated into listening, talking and unhappy clips.</a:t>
+            </a:r>
+          </a:p>
+          <a:p>
+            <a:pPr algn="l">
+              <a:spcAft>
+                <a:spcPts val="600"/>
+              </a:spcAft>
+            </a:pPr>
+            <a:r>
+              <a:rPr sz="950" i="0">
+                <a:solidFill>
+                  <a:srgbClr val="1A73E8"/>
+                </a:solidFill>
+                <a:latin typeface="Google Sans Flex SemiBold"/>
+              </a:rPr>
               <a:t>Also: </a:t>
             </a:r>
             <a:r>
@@ -21738,7 +21763,7 @@
                 </a:solidFill>
                 <a:latin typeface="Google Sans Flex"/>
               </a:rPr>
-              <a:t>Python 3.12, Next.js 15, React, Server-Sent Events, Web Speech API.</a:t>
+              <a:t>Python 3.12, Next.js 15, three.js VRM avatar, MediaPipe on-device vision, Web Speech API.</a:t>
             </a:r>
           </a:p>
         </p:txBody>

</xml_diff>